<commit_message>
Ricostruisce il marchio come Mignon Experience
Il file logo disponibile porta il vecchio logotipo Mignon.Wine, quindi il
marchio nelle tavole ora combina le quattro bottiglie originali con il
logotipo Mignon Experience e il sottotitolo le piu piccole impostati come
testo vivo. Cosi si ricolora per fondo chiaro o scuro e resta modificabile
anche nelle esportazioni PPTX e SVG.

Le bottiglie sono ritagliate mantenendo la fascia verticale comune, cosi
distanze e sfalsamento in altezza restano quelli del marchio.

Co-Authored-By: Claude Opus 5 <noreply@anthropic.com>
Claude-Session: https://claude.ai/code/session_011AShaq6CZ9yaVHz2N7dKhy
</commit_message>
<xml_diff>
--- a/mignon-avvento/export/tavole-post-1080x1350.pptx
+++ b/mignon-avvento/export/tavole-post-1080x1350.pptx
@@ -3141,7 +3141,7 @@
       </p:sp>
       <p:pic>
         <p:nvPicPr>
-          <p:cNvPr id="3" name="Picture 2" descr="logo-chiaro.png"/>
+          <p:cNvPr id="3" name="Picture 2" descr="bottiglie.png"/>
           <p:cNvPicPr>
             <a:picLocks noChangeAspect="1"/>
           </p:cNvPicPr>
@@ -3155,8 +3155,8 @@
         </p:blipFill>
         <p:spPr>
           <a:xfrm>
-            <a:off x="685800" y="685800"/>
-            <a:ext cx="1562100" cy="1333500"/>
+            <a:off x="685800" y="628650"/>
+            <a:ext cx="904875" cy="1066800"/>
           </a:xfrm>
           <a:prstGeom prst="rect">
             <a:avLst/>
@@ -3166,6 +3166,84 @@
       <p:sp>
         <p:nvSpPr>
           <p:cNvPr id="4" name="TextBox 3"/>
+          <p:cNvSpPr txBox="1"/>
+          <p:nvPr/>
+        </p:nvSpPr>
+        <p:spPr>
+          <a:xfrm>
+            <a:off x="685800" y="1838325"/>
+            <a:ext cx="2366010" cy="360045"/>
+          </a:xfrm>
+          <a:prstGeom prst="rect">
+            <a:avLst/>
+          </a:prstGeom>
+          <a:noFill/>
+        </p:spPr>
+        <p:txBody>
+          <a:bodyPr wrap="square" lIns="0" rIns="0" tIns="0" bIns="0" anchor="t">
+            <a:spAutoFit/>
+          </a:bodyPr>
+          <a:lstStyle/>
+          <a:p>
+            <a:pPr algn="l">
+              <a:lnSpc>
+                <a:spcPct val="105000"/>
+              </a:lnSpc>
+            </a:pPr>
+            <a:r>
+              <a:rPr sz="2025" b="1" i="0">
+                <a:solidFill>
+                  <a:srgbClr val="F3ECE2"/>
+                </a:solidFill>
+                <a:latin typeface="Montserrat"/>
+              </a:rPr>
+              <a:t>Mignon Experience</a:t>
+            </a:r>
+          </a:p>
+        </p:txBody>
+      </p:sp>
+      <p:sp>
+        <p:nvSpPr>
+          <p:cNvPr id="5" name="TextBox 4"/>
+          <p:cNvSpPr txBox="1"/>
+          <p:nvPr/>
+        </p:nvSpPr>
+        <p:spPr>
+          <a:xfrm>
+            <a:off x="685800" y="2185511"/>
+            <a:ext cx="2366010" cy="209550"/>
+          </a:xfrm>
+          <a:prstGeom prst="rect">
+            <a:avLst/>
+          </a:prstGeom>
+          <a:noFill/>
+        </p:spPr>
+        <p:txBody>
+          <a:bodyPr wrap="square" lIns="0" rIns="0" tIns="0" bIns="0" anchor="t">
+            <a:spAutoFit/>
+          </a:bodyPr>
+          <a:lstStyle/>
+          <a:p>
+            <a:pPr algn="l">
+              <a:lnSpc>
+                <a:spcPct val="125000"/>
+              </a:lnSpc>
+            </a:pPr>
+            <a:r>
+              <a:rPr sz="825" b="0" i="0" spc="247">
+                <a:solidFill>
+                  <a:srgbClr val="A2968A"/>
+                </a:solidFill>
+                <a:latin typeface="Montserrat"/>
+              </a:rPr>
+              <a:t>LE PIÙ PICCOLE</a:t>
+            </a:r>
+          </a:p>
+        </p:txBody>
+      </p:sp>
+      <p:sp>
+        <p:nvSpPr>
+          <p:cNvPr id="6" name="TextBox 5"/>
           <p:cNvSpPr txBox="1"/>
           <p:nvPr/>
         </p:nvSpPr>
@@ -3220,7 +3298,7 @@
       </p:sp>
       <p:sp>
         <p:nvSpPr>
-          <p:cNvPr id="5" name="TextBox 4"/>
+          <p:cNvPr id="7" name="TextBox 6"/>
           <p:cNvSpPr txBox="1"/>
           <p:nvPr/>
         </p:nvSpPr>
@@ -3259,7 +3337,7 @@
       </p:sp>
       <p:sp>
         <p:nvSpPr>
-          <p:cNvPr id="6" name="TextBox 5"/>
+          <p:cNvPr id="8" name="TextBox 7"/>
           <p:cNvSpPr txBox="1"/>
           <p:nvPr/>
         </p:nvSpPr>
@@ -3323,7 +3401,7 @@
       </p:sp>
       <p:sp>
         <p:nvSpPr>
-          <p:cNvPr id="7" name="Rectangle 6"/>
+          <p:cNvPr id="9" name="Rectangle 8"/>
           <p:cNvSpPr/>
           <p:nvPr/>
         </p:nvSpPr>
@@ -3367,7 +3445,7 @@
       </p:sp>
       <p:sp>
         <p:nvSpPr>
-          <p:cNvPr id="8" name="TextBox 7"/>
+          <p:cNvPr id="10" name="TextBox 9"/>
           <p:cNvSpPr txBox="1"/>
           <p:nvPr/>
         </p:nvSpPr>
@@ -3406,7 +3484,7 @@
       </p:sp>
       <p:sp>
         <p:nvSpPr>
-          <p:cNvPr id="9" name="Rectangle 8"/>
+          <p:cNvPr id="11" name="Rectangle 10"/>
           <p:cNvSpPr/>
           <p:nvPr/>
         </p:nvSpPr>
@@ -3450,7 +3528,7 @@
       </p:sp>
       <p:sp>
         <p:nvSpPr>
-          <p:cNvPr id="10" name="TextBox 9"/>
+          <p:cNvPr id="12" name="TextBox 11"/>
           <p:cNvSpPr txBox="1"/>
           <p:nvPr/>
         </p:nvSpPr>
@@ -3489,7 +3567,7 @@
       </p:sp>
       <p:sp>
         <p:nvSpPr>
-          <p:cNvPr id="11" name="TextBox 10"/>
+          <p:cNvPr id="13" name="TextBox 12"/>
           <p:cNvSpPr txBox="1"/>
           <p:nvPr/>
         </p:nvSpPr>
@@ -3544,7 +3622,7 @@
       </p:sp>
       <p:sp>
         <p:nvSpPr>
-          <p:cNvPr id="12" name="Rectangle 11"/>
+          <p:cNvPr id="14" name="Rectangle 13"/>
           <p:cNvSpPr/>
           <p:nvPr/>
         </p:nvSpPr>
@@ -3588,7 +3666,7 @@
       </p:sp>
       <p:sp>
         <p:nvSpPr>
-          <p:cNvPr id="13" name="TextBox 12"/>
+          <p:cNvPr id="15" name="TextBox 14"/>
           <p:cNvSpPr txBox="1"/>
           <p:nvPr/>
         </p:nvSpPr>
@@ -3627,7 +3705,7 @@
       </p:sp>
       <p:sp>
         <p:nvSpPr>
-          <p:cNvPr id="14" name="TextBox 13"/>
+          <p:cNvPr id="16" name="TextBox 15"/>
           <p:cNvSpPr txBox="1"/>
           <p:nvPr/>
         </p:nvSpPr>
@@ -3682,7 +3760,7 @@
       </p:sp>
       <p:sp>
         <p:nvSpPr>
-          <p:cNvPr id="15" name="Rectangle 14"/>
+          <p:cNvPr id="17" name="Rectangle 16"/>
           <p:cNvSpPr/>
           <p:nvPr/>
         </p:nvSpPr>
@@ -3726,7 +3804,7 @@
       </p:sp>
       <p:sp>
         <p:nvSpPr>
-          <p:cNvPr id="16" name="TextBox 15"/>
+          <p:cNvPr id="18" name="TextBox 17"/>
           <p:cNvSpPr txBox="1"/>
           <p:nvPr/>
         </p:nvSpPr>
@@ -3765,7 +3843,7 @@
       </p:sp>
       <p:sp>
         <p:nvSpPr>
-          <p:cNvPr id="17" name="TextBox 16"/>
+          <p:cNvPr id="19" name="TextBox 18"/>
           <p:cNvSpPr txBox="1"/>
           <p:nvPr/>
         </p:nvSpPr>
@@ -3820,7 +3898,7 @@
       </p:sp>
       <p:sp>
         <p:nvSpPr>
-          <p:cNvPr id="18" name="Rectangle 17"/>
+          <p:cNvPr id="20" name="Rectangle 19"/>
           <p:cNvSpPr/>
           <p:nvPr/>
         </p:nvSpPr>
@@ -3864,7 +3942,7 @@
       </p:sp>
       <p:sp>
         <p:nvSpPr>
-          <p:cNvPr id="19" name="TextBox 18"/>
+          <p:cNvPr id="21" name="TextBox 20"/>
           <p:cNvSpPr txBox="1"/>
           <p:nvPr/>
         </p:nvSpPr>
@@ -3903,7 +3981,7 @@
       </p:sp>
       <p:sp>
         <p:nvSpPr>
-          <p:cNvPr id="20" name="TextBox 19"/>
+          <p:cNvPr id="22" name="TextBox 21"/>
           <p:cNvSpPr txBox="1"/>
           <p:nvPr/>
         </p:nvSpPr>
@@ -3958,7 +4036,7 @@
       </p:sp>
       <p:sp>
         <p:nvSpPr>
-          <p:cNvPr id="21" name="TextBox 20"/>
+          <p:cNvPr id="23" name="TextBox 22"/>
           <p:cNvSpPr txBox="1"/>
           <p:nvPr/>
         </p:nvSpPr>
@@ -3997,7 +4075,7 @@
       </p:sp>
       <p:sp>
         <p:nvSpPr>
-          <p:cNvPr id="22" name="TextBox 21"/>
+          <p:cNvPr id="24" name="TextBox 23"/>
           <p:cNvSpPr txBox="1"/>
           <p:nvPr/>
         </p:nvSpPr>
@@ -4098,7 +4176,7 @@
       </p:sp>
       <p:pic>
         <p:nvPicPr>
-          <p:cNvPr id="3" name="Picture 2" descr="logo.png"/>
+          <p:cNvPr id="3" name="Picture 2" descr="bottiglie.png"/>
           <p:cNvPicPr>
             <a:picLocks noChangeAspect="1"/>
           </p:cNvPicPr>
@@ -4112,8 +4190,8 @@
         </p:blipFill>
         <p:spPr>
           <a:xfrm>
-            <a:off x="533400" y="533400"/>
-            <a:ext cx="1162050" cy="990600"/>
+            <a:off x="533400" y="476250"/>
+            <a:ext cx="704850" cy="838200"/>
           </a:xfrm>
           <a:prstGeom prst="rect">
             <a:avLst/>
@@ -4123,6 +4201,84 @@
       <p:sp>
         <p:nvSpPr>
           <p:cNvPr id="4" name="TextBox 3"/>
+          <p:cNvSpPr txBox="1"/>
+          <p:nvPr/>
+        </p:nvSpPr>
+        <p:spPr>
+          <a:xfrm>
+            <a:off x="533400" y="1419225"/>
+            <a:ext cx="1840230" cy="280035"/>
+          </a:xfrm>
+          <a:prstGeom prst="rect">
+            <a:avLst/>
+          </a:prstGeom>
+          <a:noFill/>
+        </p:spPr>
+        <p:txBody>
+          <a:bodyPr wrap="square" lIns="0" rIns="0" tIns="0" bIns="0" anchor="t">
+            <a:spAutoFit/>
+          </a:bodyPr>
+          <a:lstStyle/>
+          <a:p>
+            <a:pPr algn="l">
+              <a:lnSpc>
+                <a:spcPct val="105000"/>
+              </a:lnSpc>
+            </a:pPr>
+            <a:r>
+              <a:rPr sz="1575" b="1" i="0">
+                <a:solidFill>
+                  <a:srgbClr val="4A4A52"/>
+                </a:solidFill>
+                <a:latin typeface="Montserrat"/>
+              </a:rPr>
+              <a:t>Mignon Experience</a:t>
+            </a:r>
+          </a:p>
+        </p:txBody>
+      </p:sp>
+      <p:sp>
+        <p:nvSpPr>
+          <p:cNvPr id="5" name="TextBox 4"/>
+          <p:cNvSpPr txBox="1"/>
+          <p:nvPr/>
+        </p:nvSpPr>
+        <p:spPr>
+          <a:xfrm>
+            <a:off x="533400" y="1689258"/>
+            <a:ext cx="1840230" cy="171450"/>
+          </a:xfrm>
+          <a:prstGeom prst="rect">
+            <a:avLst/>
+          </a:prstGeom>
+          <a:noFill/>
+        </p:spPr>
+        <p:txBody>
+          <a:bodyPr wrap="square" lIns="0" rIns="0" tIns="0" bIns="0" anchor="t">
+            <a:spAutoFit/>
+          </a:bodyPr>
+          <a:lstStyle/>
+          <a:p>
+            <a:pPr algn="l">
+              <a:lnSpc>
+                <a:spcPct val="125000"/>
+              </a:lnSpc>
+            </a:pPr>
+            <a:r>
+              <a:rPr sz="675" b="0" i="0" spc="202">
+                <a:solidFill>
+                  <a:srgbClr val="8A8A92"/>
+                </a:solidFill>
+                <a:latin typeface="Montserrat"/>
+              </a:rPr>
+              <a:t>LE PIÙ PICCOLE</a:t>
+            </a:r>
+          </a:p>
+        </p:txBody>
+      </p:sp>
+      <p:sp>
+        <p:nvSpPr>
+          <p:cNvPr id="6" name="TextBox 5"/>
           <p:cNvSpPr txBox="1"/>
           <p:nvPr/>
         </p:nvSpPr>
@@ -4177,7 +4333,7 @@
       </p:sp>
       <p:sp>
         <p:nvSpPr>
-          <p:cNvPr id="5" name="TextBox 4"/>
+          <p:cNvPr id="7" name="TextBox 6"/>
           <p:cNvSpPr txBox="1"/>
           <p:nvPr/>
         </p:nvSpPr>
@@ -4266,7 +4422,7 @@
       </p:sp>
       <p:sp>
         <p:nvSpPr>
-          <p:cNvPr id="6" name="TextBox 5"/>
+          <p:cNvPr id="8" name="TextBox 7"/>
           <p:cNvSpPr txBox="1"/>
           <p:nvPr/>
         </p:nvSpPr>
@@ -4305,7 +4461,7 @@
       </p:sp>
       <p:sp>
         <p:nvSpPr>
-          <p:cNvPr id="7" name="Rectangle 6"/>
+          <p:cNvPr id="9" name="Rectangle 8"/>
           <p:cNvSpPr/>
           <p:nvPr/>
         </p:nvSpPr>
@@ -4349,7 +4505,7 @@
       </p:sp>
       <p:sp>
         <p:nvSpPr>
-          <p:cNvPr id="8" name="TextBox 7"/>
+          <p:cNvPr id="10" name="TextBox 9"/>
           <p:cNvSpPr txBox="1"/>
           <p:nvPr/>
         </p:nvSpPr>
@@ -4388,7 +4544,7 @@
       </p:sp>
       <p:sp>
         <p:nvSpPr>
-          <p:cNvPr id="9" name="Rectangle 8"/>
+          <p:cNvPr id="11" name="Rectangle 10"/>
           <p:cNvSpPr/>
           <p:nvPr/>
         </p:nvSpPr>
@@ -4432,7 +4588,7 @@
       </p:sp>
       <p:sp>
         <p:nvSpPr>
-          <p:cNvPr id="10" name="TextBox 9"/>
+          <p:cNvPr id="12" name="TextBox 11"/>
           <p:cNvSpPr txBox="1"/>
           <p:nvPr/>
         </p:nvSpPr>
@@ -4471,7 +4627,7 @@
       </p:sp>
       <p:sp>
         <p:nvSpPr>
-          <p:cNvPr id="11" name="Rectangle 10"/>
+          <p:cNvPr id="13" name="Rectangle 12"/>
           <p:cNvSpPr/>
           <p:nvPr/>
         </p:nvSpPr>
@@ -4515,7 +4671,7 @@
       </p:sp>
       <p:sp>
         <p:nvSpPr>
-          <p:cNvPr id="12" name="TextBox 11"/>
+          <p:cNvPr id="14" name="TextBox 13"/>
           <p:cNvSpPr txBox="1"/>
           <p:nvPr/>
         </p:nvSpPr>
@@ -4554,7 +4710,7 @@
       </p:sp>
       <p:sp>
         <p:nvSpPr>
-          <p:cNvPr id="13" name="Rectangle 12"/>
+          <p:cNvPr id="15" name="Rectangle 14"/>
           <p:cNvSpPr/>
           <p:nvPr/>
         </p:nvSpPr>
@@ -4598,7 +4754,7 @@
       </p:sp>
       <p:sp>
         <p:nvSpPr>
-          <p:cNvPr id="14" name="TextBox 13"/>
+          <p:cNvPr id="16" name="TextBox 15"/>
           <p:cNvSpPr txBox="1"/>
           <p:nvPr/>
         </p:nvSpPr>
@@ -4637,7 +4793,7 @@
       </p:sp>
       <p:sp>
         <p:nvSpPr>
-          <p:cNvPr id="15" name="Rectangle 14"/>
+          <p:cNvPr id="17" name="Rectangle 16"/>
           <p:cNvSpPr/>
           <p:nvPr/>
         </p:nvSpPr>
@@ -4681,7 +4837,7 @@
       </p:sp>
       <p:sp>
         <p:nvSpPr>
-          <p:cNvPr id="16" name="TextBox 15"/>
+          <p:cNvPr id="18" name="TextBox 17"/>
           <p:cNvSpPr txBox="1"/>
           <p:nvPr/>
         </p:nvSpPr>
@@ -4720,7 +4876,7 @@
       </p:sp>
       <p:sp>
         <p:nvSpPr>
-          <p:cNvPr id="17" name="Rectangle 16"/>
+          <p:cNvPr id="19" name="Rectangle 18"/>
           <p:cNvSpPr/>
           <p:nvPr/>
         </p:nvSpPr>
@@ -4764,7 +4920,7 @@
       </p:sp>
       <p:sp>
         <p:nvSpPr>
-          <p:cNvPr id="18" name="TextBox 17"/>
+          <p:cNvPr id="20" name="TextBox 19"/>
           <p:cNvSpPr txBox="1"/>
           <p:nvPr/>
         </p:nvSpPr>
@@ -4803,7 +4959,7 @@
       </p:sp>
       <p:sp>
         <p:nvSpPr>
-          <p:cNvPr id="19" name="Rectangle 18"/>
+          <p:cNvPr id="21" name="Rectangle 20"/>
           <p:cNvSpPr/>
           <p:nvPr/>
         </p:nvSpPr>
@@ -4847,7 +5003,7 @@
       </p:sp>
       <p:sp>
         <p:nvSpPr>
-          <p:cNvPr id="20" name="TextBox 19"/>
+          <p:cNvPr id="22" name="TextBox 21"/>
           <p:cNvSpPr txBox="1"/>
           <p:nvPr/>
         </p:nvSpPr>
@@ -4886,7 +5042,7 @@
       </p:sp>
       <p:sp>
         <p:nvSpPr>
-          <p:cNvPr id="21" name="Rectangle 20"/>
+          <p:cNvPr id="23" name="Rectangle 22"/>
           <p:cNvSpPr/>
           <p:nvPr/>
         </p:nvSpPr>
@@ -4930,7 +5086,7 @@
       </p:sp>
       <p:sp>
         <p:nvSpPr>
-          <p:cNvPr id="22" name="TextBox 21"/>
+          <p:cNvPr id="24" name="TextBox 23"/>
           <p:cNvSpPr txBox="1"/>
           <p:nvPr/>
         </p:nvSpPr>
@@ -4969,7 +5125,7 @@
       </p:sp>
       <p:sp>
         <p:nvSpPr>
-          <p:cNvPr id="23" name="Rectangle 22"/>
+          <p:cNvPr id="25" name="Rectangle 24"/>
           <p:cNvSpPr/>
           <p:nvPr/>
         </p:nvSpPr>
@@ -5013,7 +5169,7 @@
       </p:sp>
       <p:sp>
         <p:nvSpPr>
-          <p:cNvPr id="24" name="TextBox 23"/>
+          <p:cNvPr id="26" name="TextBox 25"/>
           <p:cNvSpPr txBox="1"/>
           <p:nvPr/>
         </p:nvSpPr>
@@ -5052,7 +5208,7 @@
       </p:sp>
       <p:sp>
         <p:nvSpPr>
-          <p:cNvPr id="25" name="Rectangle 24"/>
+          <p:cNvPr id="27" name="Rectangle 26"/>
           <p:cNvSpPr/>
           <p:nvPr/>
         </p:nvSpPr>
@@ -5096,7 +5252,7 @@
       </p:sp>
       <p:sp>
         <p:nvSpPr>
-          <p:cNvPr id="26" name="TextBox 25"/>
+          <p:cNvPr id="28" name="TextBox 27"/>
           <p:cNvSpPr txBox="1"/>
           <p:nvPr/>
         </p:nvSpPr>
@@ -5135,7 +5291,7 @@
       </p:sp>
       <p:sp>
         <p:nvSpPr>
-          <p:cNvPr id="27" name="Rectangle 26"/>
+          <p:cNvPr id="29" name="Rectangle 28"/>
           <p:cNvSpPr/>
           <p:nvPr/>
         </p:nvSpPr>
@@ -5179,7 +5335,7 @@
       </p:sp>
       <p:sp>
         <p:nvSpPr>
-          <p:cNvPr id="28" name="TextBox 27"/>
+          <p:cNvPr id="30" name="TextBox 29"/>
           <p:cNvSpPr txBox="1"/>
           <p:nvPr/>
         </p:nvSpPr>
@@ -5218,7 +5374,7 @@
       </p:sp>
       <p:sp>
         <p:nvSpPr>
-          <p:cNvPr id="29" name="Rectangle 28"/>
+          <p:cNvPr id="31" name="Rectangle 30"/>
           <p:cNvSpPr/>
           <p:nvPr/>
         </p:nvSpPr>
@@ -5262,7 +5418,7 @@
       </p:sp>
       <p:sp>
         <p:nvSpPr>
-          <p:cNvPr id="30" name="TextBox 29"/>
+          <p:cNvPr id="32" name="TextBox 31"/>
           <p:cNvSpPr txBox="1"/>
           <p:nvPr/>
         </p:nvSpPr>
@@ -5301,7 +5457,7 @@
       </p:sp>
       <p:sp>
         <p:nvSpPr>
-          <p:cNvPr id="31" name="TextBox 30"/>
+          <p:cNvPr id="33" name="TextBox 32"/>
           <p:cNvSpPr txBox="1"/>
           <p:nvPr/>
         </p:nvSpPr>
@@ -5340,7 +5496,7 @@
       </p:sp>
       <p:sp>
         <p:nvSpPr>
-          <p:cNvPr id="32" name="Rectangle 31"/>
+          <p:cNvPr id="34" name="Rectangle 33"/>
           <p:cNvSpPr/>
           <p:nvPr/>
         </p:nvSpPr>
@@ -5384,7 +5540,7 @@
       </p:sp>
       <p:sp>
         <p:nvSpPr>
-          <p:cNvPr id="33" name="TextBox 32"/>
+          <p:cNvPr id="35" name="TextBox 34"/>
           <p:cNvSpPr txBox="1"/>
           <p:nvPr/>
         </p:nvSpPr>
@@ -5423,7 +5579,7 @@
       </p:sp>
       <p:sp>
         <p:nvSpPr>
-          <p:cNvPr id="34" name="TextBox 33"/>
+          <p:cNvPr id="36" name="TextBox 35"/>
           <p:cNvSpPr txBox="1"/>
           <p:nvPr/>
         </p:nvSpPr>
@@ -5524,7 +5680,7 @@
       </p:sp>
       <p:pic>
         <p:nvPicPr>
-          <p:cNvPr id="3" name="Picture 2" descr="logo.png"/>
+          <p:cNvPr id="3" name="Picture 2" descr="bottiglie.png"/>
           <p:cNvPicPr>
             <a:picLocks noChangeAspect="1"/>
           </p:cNvPicPr>
@@ -5538,8 +5694,8 @@
         </p:blipFill>
         <p:spPr>
           <a:xfrm>
-            <a:off x="4205287" y="914400"/>
-            <a:ext cx="1876425" cy="1600200"/>
+            <a:off x="5143500" y="914400"/>
+            <a:ext cx="1209675" cy="1428750"/>
           </a:xfrm>
           <a:prstGeom prst="rect">
             <a:avLst/>
@@ -5549,6 +5705,84 @@
       <p:sp>
         <p:nvSpPr>
           <p:cNvPr id="4" name="TextBox 3"/>
+          <p:cNvSpPr txBox="1"/>
+          <p:nvPr/>
+        </p:nvSpPr>
+        <p:spPr>
+          <a:xfrm>
+            <a:off x="4170997" y="2533650"/>
+            <a:ext cx="3154680" cy="480060"/>
+          </a:xfrm>
+          <a:prstGeom prst="rect">
+            <a:avLst/>
+          </a:prstGeom>
+          <a:noFill/>
+        </p:spPr>
+        <p:txBody>
+          <a:bodyPr wrap="square" lIns="0" rIns="0" tIns="0" bIns="0" anchor="t">
+            <a:spAutoFit/>
+          </a:bodyPr>
+          <a:lstStyle/>
+          <a:p>
+            <a:pPr algn="ctr">
+              <a:lnSpc>
+                <a:spcPct val="105000"/>
+              </a:lnSpc>
+            </a:pPr>
+            <a:r>
+              <a:rPr sz="2700" b="1" i="0">
+                <a:solidFill>
+                  <a:srgbClr val="4A4A52"/>
+                </a:solidFill>
+                <a:latin typeface="Montserrat"/>
+              </a:rPr>
+              <a:t>Mignon Experience</a:t>
+            </a:r>
+          </a:p>
+        </p:txBody>
+      </p:sp>
+      <p:sp>
+        <p:nvSpPr>
+          <p:cNvPr id="5" name="TextBox 4"/>
+          <p:cNvSpPr txBox="1"/>
+          <p:nvPr/>
+        </p:nvSpPr>
+        <p:spPr>
+          <a:xfrm>
+            <a:off x="4170997" y="2996565"/>
+            <a:ext cx="3154680" cy="285750"/>
+          </a:xfrm>
+          <a:prstGeom prst="rect">
+            <a:avLst/>
+          </a:prstGeom>
+          <a:noFill/>
+        </p:spPr>
+        <p:txBody>
+          <a:bodyPr wrap="square" lIns="0" rIns="0" tIns="0" bIns="0" anchor="t">
+            <a:spAutoFit/>
+          </a:bodyPr>
+          <a:lstStyle/>
+          <a:p>
+            <a:pPr algn="ctr">
+              <a:lnSpc>
+                <a:spcPct val="125000"/>
+              </a:lnSpc>
+            </a:pPr>
+            <a:r>
+              <a:rPr sz="1125" b="0" i="0" spc="337">
+                <a:solidFill>
+                  <a:srgbClr val="8A8A92"/>
+                </a:solidFill>
+                <a:latin typeface="Montserrat"/>
+              </a:rPr>
+              <a:t>LE PIÙ PICCOLE</a:t>
+            </a:r>
+          </a:p>
+        </p:txBody>
+      </p:sp>
+      <p:sp>
+        <p:nvSpPr>
+          <p:cNvPr id="6" name="TextBox 5"/>
           <p:cNvSpPr txBox="1"/>
           <p:nvPr/>
         </p:nvSpPr>
@@ -5603,7 +5837,7 @@
       </p:sp>
       <p:sp>
         <p:nvSpPr>
-          <p:cNvPr id="5" name="Rectangle 4"/>
+          <p:cNvPr id="7" name="Rectangle 6"/>
           <p:cNvSpPr/>
           <p:nvPr/>
         </p:nvSpPr>
@@ -5647,7 +5881,7 @@
       </p:sp>
       <p:sp>
         <p:nvSpPr>
-          <p:cNvPr id="6" name="TextBox 5"/>
+          <p:cNvPr id="8" name="TextBox 7"/>
           <p:cNvSpPr txBox="1"/>
           <p:nvPr/>
         </p:nvSpPr>
@@ -5686,7 +5920,7 @@
       </p:sp>
       <p:sp>
         <p:nvSpPr>
-          <p:cNvPr id="7" name="TextBox 6"/>
+          <p:cNvPr id="9" name="TextBox 8"/>
           <p:cNvSpPr txBox="1"/>
           <p:nvPr/>
         </p:nvSpPr>
@@ -5725,7 +5959,7 @@
       </p:sp>
       <p:sp>
         <p:nvSpPr>
-          <p:cNvPr id="8" name="TextBox 7"/>
+          <p:cNvPr id="10" name="TextBox 9"/>
           <p:cNvSpPr txBox="1"/>
           <p:nvPr/>
         </p:nvSpPr>
@@ -6002,7 +6236,7 @@
         <p:spPr>
           <a:xfrm>
             <a:off x="1262062" y="3429000"/>
-            <a:ext cx="95250" cy="438150"/>
+            <a:ext cx="57150" cy="438150"/>
           </a:xfrm>
           <a:prstGeom prst="rect">
             <a:avLst/>
@@ -6216,7 +6450,7 @@
         <p:spPr>
           <a:xfrm>
             <a:off x="4329112" y="3429000"/>
-            <a:ext cx="95250" cy="438150"/>
+            <a:ext cx="76200" cy="438150"/>
           </a:xfrm>
           <a:prstGeom prst="rect">
             <a:avLst/>
@@ -6430,7 +6664,7 @@
         <p:spPr>
           <a:xfrm>
             <a:off x="7396162" y="3429000"/>
-            <a:ext cx="95250" cy="438150"/>
+            <a:ext cx="66675" cy="438150"/>
           </a:xfrm>
           <a:prstGeom prst="rect">
             <a:avLst/>
@@ -6537,7 +6771,7 @@
         <p:spPr>
           <a:xfrm>
             <a:off x="8929687" y="3429000"/>
-            <a:ext cx="95250" cy="438150"/>
+            <a:ext cx="57150" cy="438150"/>
           </a:xfrm>
           <a:prstGeom prst="rect">
             <a:avLst/>
@@ -6751,7 +6985,7 @@
         <p:spPr>
           <a:xfrm>
             <a:off x="2795587" y="4962525"/>
-            <a:ext cx="95250" cy="438150"/>
+            <a:ext cx="76200" cy="438150"/>
           </a:xfrm>
           <a:prstGeom prst="rect">
             <a:avLst/>
@@ -6858,7 +7092,7 @@
         <p:spPr>
           <a:xfrm>
             <a:off x="4329112" y="4962525"/>
-            <a:ext cx="95250" cy="438150"/>
+            <a:ext cx="57150" cy="438150"/>
           </a:xfrm>
           <a:prstGeom prst="rect">
             <a:avLst/>
@@ -7072,7 +7306,7 @@
         <p:spPr>
           <a:xfrm>
             <a:off x="7396162" y="4962525"/>
-            <a:ext cx="95250" cy="438150"/>
+            <a:ext cx="66675" cy="438150"/>
           </a:xfrm>
           <a:prstGeom prst="rect">
             <a:avLst/>
@@ -7179,7 +7413,7 @@
         <p:spPr>
           <a:xfrm>
             <a:off x="8929687" y="4962525"/>
-            <a:ext cx="95250" cy="438150"/>
+            <a:ext cx="76200" cy="438150"/>
           </a:xfrm>
           <a:prstGeom prst="rect">
             <a:avLst/>
@@ -7286,7 +7520,7 @@
         <p:spPr>
           <a:xfrm>
             <a:off x="1262062" y="6496050"/>
-            <a:ext cx="95250" cy="438150"/>
+            <a:ext cx="57150" cy="438150"/>
           </a:xfrm>
           <a:prstGeom prst="rect">
             <a:avLst/>
@@ -7500,7 +7734,7 @@
         <p:spPr>
           <a:xfrm>
             <a:off x="4329112" y="6496050"/>
-            <a:ext cx="95250" cy="438150"/>
+            <a:ext cx="76200" cy="438150"/>
           </a:xfrm>
           <a:prstGeom prst="rect">
             <a:avLst/>
@@ -7607,7 +7841,7 @@
         <p:spPr>
           <a:xfrm>
             <a:off x="5862637" y="6496050"/>
-            <a:ext cx="95250" cy="438150"/>
+            <a:ext cx="66675" cy="438150"/>
           </a:xfrm>
           <a:prstGeom prst="rect">
             <a:avLst/>
@@ -7821,7 +8055,7 @@
         <p:spPr>
           <a:xfrm>
             <a:off x="8929687" y="6496050"/>
-            <a:ext cx="95250" cy="438150"/>
+            <a:ext cx="57150" cy="438150"/>
           </a:xfrm>
           <a:prstGeom prst="rect">
             <a:avLst/>
@@ -7928,7 +8162,7 @@
         <p:spPr>
           <a:xfrm>
             <a:off x="1262062" y="8029575"/>
-            <a:ext cx="95250" cy="438150"/>
+            <a:ext cx="76200" cy="438150"/>
           </a:xfrm>
           <a:prstGeom prst="rect">
             <a:avLst/>
@@ -8142,7 +8376,7 @@
         <p:spPr>
           <a:xfrm>
             <a:off x="4329112" y="8029575"/>
-            <a:ext cx="95250" cy="438150"/>
+            <a:ext cx="66675" cy="438150"/>
           </a:xfrm>
           <a:prstGeom prst="rect">
             <a:avLst/>
@@ -8249,7 +8483,7 @@
         <p:spPr>
           <a:xfrm>
             <a:off x="5862637" y="8029575"/>
-            <a:ext cx="95250" cy="438150"/>
+            <a:ext cx="57150" cy="438150"/>
           </a:xfrm>
           <a:prstGeom prst="rect">
             <a:avLst/>
@@ -10183,7 +10417,7 @@
         <p:spPr>
           <a:xfrm>
             <a:off x="4667250" y="4000500"/>
-            <a:ext cx="247650" cy="1143000"/>
+            <a:ext cx="152400" cy="1143000"/>
           </a:xfrm>
           <a:prstGeom prst="rect">
             <a:avLst/>
@@ -10231,7 +10465,7 @@
         <p:spPr>
           <a:xfrm>
             <a:off x="5429250" y="4000500"/>
-            <a:ext cx="238125" cy="1143000"/>
+            <a:ext cx="209550" cy="1143000"/>
           </a:xfrm>
           <a:prstGeom prst="rect">
             <a:avLst/>
@@ -10416,7 +10650,7 @@
         <p:spPr>
           <a:xfrm>
             <a:off x="7696200" y="4000500"/>
-            <a:ext cx="247650" cy="1143000"/>
+            <a:ext cx="171450" cy="1143000"/>
           </a:xfrm>
           <a:prstGeom prst="rect">
             <a:avLst/>
@@ -10440,7 +10674,7 @@
         <p:spPr>
           <a:xfrm>
             <a:off x="8077200" y="4000500"/>
-            <a:ext cx="247650" cy="1143000"/>
+            <a:ext cx="152400" cy="1143000"/>
           </a:xfrm>
           <a:prstGeom prst="rect">
             <a:avLst/>
@@ -11841,7 +12075,7 @@
         <p:spPr>
           <a:xfrm>
             <a:off x="1476375" y="3429000"/>
-            <a:ext cx="647700" cy="3143250"/>
+            <a:ext cx="657225" cy="3143250"/>
           </a:xfrm>
           <a:prstGeom prst="rect">
             <a:avLst/>
@@ -12538,7 +12772,7 @@
       </p:sp>
       <p:pic>
         <p:nvPicPr>
-          <p:cNvPr id="24" name="Picture 23" descr="logo-chiaro.png"/>
+          <p:cNvPr id="24" name="Picture 23" descr="bottiglie.png"/>
           <p:cNvPicPr>
             <a:picLocks noChangeAspect="1"/>
           </p:cNvPicPr>
@@ -12552,8 +12786,8 @@
         </p:blipFill>
         <p:spPr>
           <a:xfrm>
-            <a:off x="609600" y="11811000"/>
-            <a:ext cx="847725" cy="723900"/>
+            <a:off x="609600" y="11582400"/>
+            <a:ext cx="485775" cy="571500"/>
           </a:xfrm>
           <a:prstGeom prst="rect">
             <a:avLst/>
@@ -12563,6 +12797,84 @@
       <p:sp>
         <p:nvSpPr>
           <p:cNvPr id="25" name="TextBox 24"/>
+          <p:cNvSpPr txBox="1"/>
+          <p:nvPr/>
+        </p:nvSpPr>
+        <p:spPr>
+          <a:xfrm>
+            <a:off x="609600" y="12230100"/>
+            <a:ext cx="1489709" cy="226694"/>
+          </a:xfrm>
+          <a:prstGeom prst="rect">
+            <a:avLst/>
+          </a:prstGeom>
+          <a:noFill/>
+        </p:spPr>
+        <p:txBody>
+          <a:bodyPr wrap="square" lIns="0" rIns="0" tIns="0" bIns="0" anchor="t">
+            <a:spAutoFit/>
+          </a:bodyPr>
+          <a:lstStyle/>
+          <a:p>
+            <a:pPr algn="l">
+              <a:lnSpc>
+                <a:spcPct val="105000"/>
+              </a:lnSpc>
+            </a:pPr>
+            <a:r>
+              <a:rPr sz="1275" b="1" i="0">
+                <a:solidFill>
+                  <a:srgbClr val="F3ECE2"/>
+                </a:solidFill>
+                <a:latin typeface="Montserrat"/>
+              </a:rPr>
+              <a:t>Mignon Experience</a:t>
+            </a:r>
+          </a:p>
+        </p:txBody>
+      </p:sp>
+      <p:sp>
+        <p:nvSpPr>
+          <p:cNvPr id="26" name="TextBox 25"/>
+          <p:cNvSpPr txBox="1"/>
+          <p:nvPr/>
+        </p:nvSpPr>
+        <p:spPr>
+          <a:xfrm>
+            <a:off x="609600" y="12448698"/>
+            <a:ext cx="1489709" cy="152400"/>
+          </a:xfrm>
+          <a:prstGeom prst="rect">
+            <a:avLst/>
+          </a:prstGeom>
+          <a:noFill/>
+        </p:spPr>
+        <p:txBody>
+          <a:bodyPr wrap="square" lIns="0" rIns="0" tIns="0" bIns="0" anchor="t">
+            <a:spAutoFit/>
+          </a:bodyPr>
+          <a:lstStyle/>
+          <a:p>
+            <a:pPr algn="l">
+              <a:lnSpc>
+                <a:spcPct val="125000"/>
+              </a:lnSpc>
+            </a:pPr>
+            <a:r>
+              <a:rPr sz="600" b="0" i="0" spc="179">
+                <a:solidFill>
+                  <a:srgbClr val="A2968A"/>
+                </a:solidFill>
+                <a:latin typeface="Montserrat"/>
+              </a:rPr>
+              <a:t>LE PIÙ PICCOLE</a:t>
+            </a:r>
+          </a:p>
+        </p:txBody>
+      </p:sp>
+      <p:sp>
+        <p:nvSpPr>
+          <p:cNvPr id="27" name="TextBox 26"/>
           <p:cNvSpPr txBox="1"/>
           <p:nvPr/>
         </p:nvSpPr>

</xml_diff>